<commit_message>
fix: visible accent tick on all covers + robustness/portability hardening (repo audit)
From a multi-angle read-only audit:
- Correctness: cover()/closing()/divider() now use the _bar_on() helper (was dead
  code) so the accent tick stays visible on the 11 brands where divider_bg==accent
  (samsung-sdi, kakao, lg-*, hyundai-motor, posco, doosan, shinhan, toss, upstage,
  nongshim). Re-rendered all; gallery updated.
- Robustness: charts KR-font detection now also finds ~/.fonts (Linux install path);
  icons.py sanitizes icon names (no path traversal); place_images bounds-checks slide
  index; persistent icon cache at ~/.cache/kr-brand-decks/icons (faster, offline-able).
- Docs: gen_skill description lists the real layout set; stale 20/18 counts fixed;
  README notes shared-engine location for install troubleshooting.

Co-Authored-By: Claude Opus 4.8 <noreply@anthropic.com>
</commit_message>
<xml_diff>
--- a/skills/deck-doosan/examples/doosan-6p.pptx
+++ b/skills/deck-doosan/examples/doosan-6p.pptx
@@ -3121,7 +3121,7 @@
             <a:avLst/>
           </a:prstGeom>
           <a:solidFill>
-            <a:srgbClr val="0017A8"/>
+            <a:srgbClr val="FFFFFF"/>
           </a:solidFill>
           <a:ln>
             <a:noFill/>
@@ -3629,7 +3629,7 @@
             <a:avLst/>
           </a:prstGeom>
           <a:solidFill>
-            <a:srgbClr val="0017A8"/>
+            <a:srgbClr val="FFFFFF"/>
           </a:solidFill>
           <a:ln>
             <a:noFill/>

</xml_diff>